<commit_message>
PHP2Shell: speaker notes în română
Co-Authored-By: Claude Opus 5.5 <noreply@anthropic.com>
</commit_message>
<xml_diff>
--- a/Talk_PHP2Shell_October_2026.pptx
+++ b/Talk_PHP2Shell_October_2026.pptx
@@ -118,14 +118,14 @@
   <p:extLst>
     <p:ext uri="{521415D9-36F7-43E2-AB2F-B90AF26B5E84}">
       <p14:sectionLst xmlns:p14="http://schemas.microsoft.com/office/powerpoint/2010/main">
-        <p14:section name="What happened" id="{58689368-23c0-fe14-558a-cd0dd98db913}">
+        <p14:section name="What happened" id="{b6d30da8-70db-19e7-2a66-6382cd73c206}">
           <p14:sldIdLst>
             <p14:sldId id="256"/>
             <p14:sldId id="257"/>
             <p14:sldId id="258"/>
           </p14:sldIdLst>
         </p14:section>
-        <p14:section name="How it works" id="{d7576959-f6ba-8cf3-95d3-af7fc869f231}">
+        <p14:section name="How it works" id="{da66a972-c30b-9fb8-36a4-633132da7bc8}">
           <p14:sldIdLst>
             <p14:sldId id="259"/>
             <p14:sldId id="260"/>
@@ -133,7 +133,7 @@
             <p14:sldId id="262"/>
           </p14:sldIdLst>
         </p14:section>
-        <p14:section name="Response" id="{b55a155d-94d7-4818-33c1-c229c2281549}">
+        <p14:section name="Response" id="{872f119e-404a-43c6-a2ea-666d6eab558e}">
           <p14:sldIdLst>
             <p14:sldId id="263"/>
             <p14:sldId id="264"/>
@@ -546,7 +546,9 @@
           <a:p>
             <a:r>
               <a:rPr lang="en-US" dirty="0"/>
-              <a:t>10-15 minute talk. Start with a question: 'Your code is perfect, no SQL injection, no XSS. Can your site still be hacked?' Answer: yes, if the runtime under it is broken. That is exactly what happened to PHP on 21 October 2026.</a:t>
+              <a:t>Durată: 10–15 minute. Începe cu o întrebare către studenți: „Codul vostru e perfect: fără SQL injection, fără XSS. Poate fi totuși spart site-ul?” Răspunsul: da, dacă e vulnerabil chiar limbajul pe care rulează. Exact asta s-a întâmplat cu PHP pe 21 octombrie 2026.
+— English —
+10-15 minute talk. Start with a question: 'Your code is perfect, no SQL injection, no XSS. Can your site still be hacked?' Answer: yes, if the runtime under it is broken. That is exactly what happened to PHP on 21 October 2026.</a:t>
             </a:r>
             <a:endParaRPr lang="en-US" dirty="0"/>
           </a:p>
@@ -634,7 +636,13 @@
           <a:p>
             <a:r>
               <a:rPr lang="en-US" dirty="0"/>
-              <a:t>Settings must be set in php.ini or the pool config; ini_set() in code is too late because the bug fires before the script starts. Ask students: which of these is defense in depth? (WAF + isolation + config hardening are layers; the patch is the real fix.)</a:t>
+              <a:t>Dacă nu poți actualiza imediat, există măsuri temporare. Ele reduc riscul, nu îl elimină.
+În php.ini sau în configurația pool-ului FPM, apoi restart: dezactivezi session.upload_progress, fatal_error_backtraces (pe 8.5), limitezi mărimea cererilor; opțional pm.max_requests=1, adică fiecare worker servește o singură cerere (scump ca performanță). Setările trebuie puse în configurație, nu cu ini_set() în cod: bug-ul se declanșează înainte să pornească scriptul.
+În fața serverului: WAF sau reverse proxy care limitează dimensiunea cererilor și numărul de părți multipart. Izolare: acces doar prin VPN sau listă de IP-uri, ori oprești serviciul (recomandarea CERT-EU). Verificare: cauți înapoi de pe 20 octombrie fișiere noi în directorul site-ului, procese lansate de php-fpm, trafic de ieșire neobișnuit.
+Ce NU ajută: ascunderea erorilor sau a versiunii PHP. Securitatea prin obscuritate nu e protecție.
+Întrebare pentru studenți: care dintre acestea sunt „apărare în adâncime”? (WAF, izolare, configurare = straturi; patch-ul = reparația reală.)
+— English —
+Settings must be set in php.ini or the pool config; ini_set() in code is too late because the bug fires before the script starts. Ask students: which of these is defense in depth? (WAF + isolation + config hardening are layers; the patch is the real fix.)</a:t>
             </a:r>
             <a:endParaRPr lang="en-US" dirty="0"/>
           </a:p>
@@ -722,7 +730,15 @@
           <a:p>
             <a:r>
               <a:rPr lang="en-US" dirty="0"/>
-              <a:t>Exposure numbers are estimates from internet scans (Mallory.ai / Phoenix Security, Modat ~4.4 million PHP services). Treat them as directional. Also worth mentioning: AI tools were used both to find these bugs and, within hours of the leak, to try to reproduce them. The time between disclosure and attack keeps shrinking.</a:t>
+              <a:t>Lecțiile pentru noi:
+1) Să știi ce rulezi. Fă inventarul fiecărui PHP: servere, containere, echipamente. Nu poți actualiza ce nu știi că există.
+2) Versiunile ieșite din suport sunt un risc. Circa 880 000 de servere publice rulau versiuni care nu au primit nicio corecție (PHP 5, 7, 8.0, 8.1).
+3) Actualizarea e un proces: rapid, imagini de container reconstruite automat, procese repornite.
+4) Apărare în adâncime: cod sigur nu ajunge. Privilegii minime pentru www-data, firewall, WAF, monitorizare.
+În laboratoare: Lab 4 (unattended-upgrades pe server) și Lab 5 (limite în Nginx, reverse proxy) sunt exact aceste controale.
+Cifrele de expunere sunt estimări din scanări ale internetului (Mallory.ai / Phoenix Security, Modat ~4,4 milioane de servicii PHP), le prezentăm ca ordine de mărime. Merită spus și că AI a fost folosit atât pentru găsirea bug-urilor, cât și, la câteva ore după scurgere, pentru încercarea de a le reproduce: timpul dintre publicare și atac se scurtează.
+— English —
+Exposure numbers are estimates from internet scans (Mallory.ai / Phoenix Security, Modat ~4.4 million PHP services). Treat them as directional. Also worth mentioning: AI tools were used both to find these bugs and, within hours of the leak, to try to reproduce them. The time between disclosure and attack keeps shrinking.</a:t>
             </a:r>
             <a:endParaRPr lang="en-US" dirty="0"/>
           </a:p>
@@ -810,7 +826,10 @@
           <a:p>
             <a:r>
               <a:rPr lang="en-US" dirty="0"/>
-              <a:t>Sources: PHP advisories GHSA-w8hw-w9fx-j79w and GHSA-6wmf-4rv5-p3rp; CISA alert 21 Oct 2026; Rapid7, Qualys, Google Cloud, Recorded Future, SANS ISC, Infosecurity Magazine, Univ. of Washington IT. Some details (exact attack counts) were still developing on 22 Oct 2026.</a:t>
+              <a:t>Încheiere și discuție: „Cum ați găsi într-o oră fiecare instalare PHP dintr-o organizație?” Răspunsuri bune: scanare de rețea, inventar de pachete pe servere, scanarea imaginilor de container, întrebat furnizorii de echipamente, căutat antetul X-Powered-By.
+Surse: advisory-urile PHP GHSA-w8hw-w9fx-j79w și GHSA-6wmf-4rv5-p3rp; alerta CISA din 21.10.2026; Rapid7, Qualys, Google Cloud, Recorded Future, SANS ISC, Infosecurity Magazine, UW-IT. Unele detalii (numărul exact de atacuri reușite) erau încă în evoluție pe 22.10.2026.
+— English —
+Sources: PHP advisories GHSA-w8hw-w9fx-j79w and GHSA-6wmf-4rv5-p3rp; CISA alert 21 Oct 2026; Rapid7, Qualys, Google Cloud, Recorded Future, SANS ISC, Infosecurity Magazine, Univ. of Washington IT. Some details (exact attack counts) were still developing on 22 Oct 2026.</a:t>
             </a:r>
             <a:endParaRPr lang="en-US" dirty="0"/>
           </a:p>
@@ -898,7 +917,11 @@
           <a:p>
             <a:r>
               <a:rPr lang="en-US" dirty="0"/>
-              <a:t>RCE = Remote Code Execution, the worst category: the attacker runs commands with the rights of the web server user (www-data). The nickname PHP2Shell means 'from a PHP request to a shell on the server'. Official score is 9.2; leaked posts before release claimed 10.0, which was wrong.</a:t>
+              <a:t>RCE (Remote Code Execution) e cea mai gravă categorie: atacatorul rulează comenzi pe server cu drepturile utilizatorului serverului web (www-data). Numele PHP2Shell înseamnă „de la o cerere PHP la un shell pe server”.
+Cifrele: scor CVSS 9.2 (oficial; postările scurse înainte de publicare spuneau 10.0, greșit). Nu e nevoie de cont, parolă sau vreun click din partea victimei. PHP rulează pe circa 70% din site-urile la care se știe limbajul de pe server. Toate versiunile de la 5.4 până la 8.5.11 sunt afectate.
+Pe lângă execuția de cod, atacatorul poate citi memoria altor cereri: parole, token-uri de sesiune, chei API.
+— English —
+RCE = Remote Code Execution, the worst category: the attacker runs commands with the rights of the web server user (www-data). The nickname PHP2Shell means 'from a PHP request to a shell on the server'. Official score is 9.2; leaked posts before release claimed 10.0, which was wrong.</a:t>
             </a:r>
             <a:endParaRPr lang="en-US" dirty="0"/>
           </a:p>
@@ -986,7 +1009,11 @@
           <a:p>
             <a:r>
               <a:rPr lang="en-US" dirty="0"/>
-              <a:t>Every server that runs PHP and answers web requests: PHP-FPM, Apache mod_php, php-cgi, FrankenPHP, LiteSpeed. mod_php was the highest priority because the exploit fires before any application code runs. PHP CLI scripts (cron jobs) are not the target, since there is no attacker-controlled HTTP request.</a:t>
+              <a:t>Afectat e orice server care rulează PHP și răspunde la cereri web: PHP-FPM, Apache mod_php, php-cgi, FrankenPHP, LiteSpeed. Prioritatea maximă a fost mod_php, pentru că atacul funcționează înainte să ruleze vreo linie din codul aplicației. Scripturile PHP rulate din linia de comandă (cron) nu sunt ținta, fiindcă acolo nu există o cerere HTTP controlată de atacator.
+Exemple concrete: Wiz a demonstrat execuție de cod pe WordPress, Drupal și Joomla. Furnizorii de firewall-uri (pfSense, OPNsense, Cisco, Palo Alto) au publicat buletine pentru produsele lor. Universitatea din Washington a tăiat accesul la rețea (null route) pentru serverele nepatchuite până la actualizare.
+Mesajul principal: codul aplicației poate fi 100% corect și totuși serverul e compromis, pentru că bug-ul e mai jos, în runtime.
+— English —
+Every server that runs PHP and answers web requests: PHP-FPM, Apache mod_php, php-cgi, FrankenPHP, LiteSpeed. mod_php was the highest priority because the exploit fires before any application code runs. PHP CLI scripts (cron jobs) are not the target, since there is no attacker-controlled HTTP request.</a:t>
             </a:r>
             <a:endParaRPr lang="en-US" dirty="0"/>
           </a:p>
@@ -1074,7 +1101,12 @@
           <a:p>
             <a:r>
               <a:rPr lang="en-US" dirty="0"/>
-              <a:t>Draw this on the board if possible. Connect to Lab 5: PHP-FPM/Nginx work exactly like this. A worker is a process; memory inside it survives from one request to the next unless PHP resets it.</a:t>
+              <a:t>Dacă se poate, desenează schema pe tablă.
+PHP-FPM și Apache nu pornesc un proces nou pentru fiecare cerere, ar fi prea lent. Țin un set de procese („workeri”) și fiecare servește mii de cereri la rând. Memoria din interiorul unui worker rămâne de la o cerere la alta, iar PHP trebuie să o curețe la final (pasul 4).
+Presupunerea pe care se bazează totul: curățarea se termină mereu corect, deci cererea B nu vede nimic din cererea A. PHP2Shell strică exact această presupunere. Ambele bug-uri sunt în pasul marcat cu roșu.
+Legătura cu cursul: în Lab 5 lucrăm cu Nginx + PHP-FPM / backend exact pe acest model.
+— English —
+Draw this on the board if possible. Connect to Lab 5: PHP-FPM/Nginx work exactly like this. A worker is a process; memory inside it survives from one request to the next unless PHP resets it.</a:t>
             </a:r>
             <a:endParaRPr lang="en-US" dirty="0"/>
           </a:p>
@@ -1162,7 +1194,12 @@
           <a:p>
             <a:r>
               <a:rPr lang="en-US" dirty="0"/>
-              <a:t>Simplified example; the public PoC used a multipart POST with an extremely long filename. The point for students: error paths are rarely tested. Code that handles 'out of memory' runs almost never in normal life, so bugs there survive for years. On mod_php the attack works before application code even starts. For PHP-FPM no full exploit was shown for this specific CVE.</a:t>
+              <a:t>Primul bug. Atacatorul trimite un POST multipart/form-data uriaș, fără antetul Content-Length (cu Transfer-Encoding: chunked). Așa, limita post_max_size nu se aplică. Mii de părți și antete umplu memoria.
+PHP rămâne fără memorie exact când datele cererii sunt pe jumătate construite și abandonează cererea. Dar rutina de curățare rulează oricum și tratează datele incomplete ca fiind valide: eliberează și folosește pointeri invalizi. Cu o așezare atentă a memoriei (heap), corupția devine execuție de cod.
+Exemplul de pe slide e simplificat, scop didactic. PoC-ul public folosea un POST multipart cu un nume de fișier extrem de lung.
+Ideea pentru studenți: căile de eroare sunt rar testate. Codul care tratează „memorie insuficientă” aproape nu rulează în viața reală, așa că bug-urile de acolo supraviețuiesc ani de zile. Pe mod_php e nevoie de o singură cerere per încercare; pentru PHP-FPM nu s-a arătat un exploit complet pentru acest CVE.
+— English —
+Simplified example; the public PoC used a multipart POST with an extremely long filename. The point for students: error paths are rarely tested. Code that handles 'out of memory' runs almost never in normal life, so bugs there survive for years. On mod_php the attack works before application code even starts. For PHP-FPM no full exploit was shown for this specific CVE.</a:t>
             </a:r>
             <a:endParaRPr lang="en-US" dirty="0"/>
           </a:p>
@@ -1250,7 +1287,12 @@
           <a:p>
             <a:r>
               <a:rPr lang="en-US" dirty="0"/>
-              <a:t>This is the cross-request bug. Two requests have to land on the same worker; the attacker just sends many pairs until it works. Important detail from the advisory: hiding errors with display_errors=Off, error_reporting or @ does NOT help. The stale data is used even if nothing is printed or logged. So 'my logs are clean' is not proof of safety.</a:t>
+              <a:t>Al doilea bug e între două cereri. Cererea 1 („producătorul”) provoacă o eroare fatală: timeout, memorie epuizată, un require eșuat. PHP se oprește înainte să reseteze o parte din starea globală (erori, sesiune, backtrace), iar acea stare arată spre memorie deja eliberată.
+Cererea 2 („consumatorul”) ajunge la același worker. Ceva rulează înainte de inițializarea normală, de exemplu progresul upload-ului din sesiune sau un avertisment de la o setare INI din .htaccess, și citește pointerul vechi: use-after-free, deci execuție de cod sau scurgere de memorie.
+Atacatorul nu controlează la ce worker ajunge, așa că trimite multe perechi de cereri până nimerește.
+Detaliu important din advisory: ascunderea erorilor (display_errors=Off, error_reporting, operatorul @) NU ajută. Starea veche e folosită chiar dacă nu se afișează și nu se loghează nimic. Deci „logurile mele sunt curate” nu e o dovadă că serverul e în siguranță.
+— English —
+This is the cross-request bug. Two requests have to land on the same worker; the attacker just sends many pairs until it works. Important detail from the advisory: hiding errors with display_errors=Off, error_reporting or @ does NOT help. The stale data is used even if nothing is printed or logged. So 'my logs are clean' is not proof of safety.</a:t>
             </a:r>
             <a:endParaRPr lang="en-US" dirty="0"/>
           </a:p>
@@ -1338,7 +1380,14 @@
           <a:p>
             <a:r>
               <a:rPr lang="en-US" dirty="0"/>
-              <a:t>Link back to Lesson 1: CVSS vector AV:N/AC:H/AT:P/PR:N/UI:N/VC:H/VI:H/VA:H. Network attack, no privileges, no user interaction, high impact on C, I and A. AC:H (high complexity) because it depends on heap layout and worker scheduling, which is why it is 9.2 and not 10.</a:t>
+              <a:t>Ce obține atacatorul:
+1) Execuție de cod ca www-data. Pasul tipic următor: un webshell, adică un fișier PHP ascuns prin care revine oricând.
+2) Chiar fără execuție de cod: citește din memorie parolele, sesiunile și cheile API ale altor utilizatori.
+3) De acolo mai departe: citește config.php, ia parola bazei de date, descarcă toată baza. Circa 394 000 de servere PHP au și SSH expus, deci se poate muta și pe alte sisteme.
+Legătura cu Lecția 1: vectorul CVSS AV:N/AC:H/AT:P/PR:N/UI:N/VC:H/VI:H/VA:H. Atac prin rețea, fără privilegii, fără interacțiunea utilizatorului, impact mare pe toate trei: confidențialitate, integritate, disponibilitate. Complexitatea e „High” pentru că depinde de așezarea memoriei și de ce worker primește cererea; de aceea 9.2 și nu 10.
+Întrebare pentru studenți: care literă din triada CIA e încălcată de fiecare dintre cele trei carduri?
+— English —
+Link back to Lesson 1: CVSS vector AV:N/AC:H/AT:P/PR:N/UI:N/VC:H/VI:H/VA:H. Network attack, no privileges, no user interaction, high impact on C, I and A. AC:H (high complexity) because it depends on heap layout and worker scheduling, which is why it is 9.2 and not 10.</a:t>
             </a:r>
             <a:endParaRPr lang="en-US" dirty="0"/>
           </a:p>
@@ -1426,7 +1475,12 @@
           <a:p>
             <a:r>
               <a:rPr lang="en-US" dirty="0"/>
-              <a:t>This is a lesson in coordinated disclosure. Normally: researcher reports privately, vendor fixes, distros prepare packages, everyone publishes on the same day. Here the CVE IDs leaked a day early and an archive with details hit VirusTotal, so attacks started hours BEFORE the patch existed. That is effectively a zero-day window. Note: reports of attacks are early; the number of successful compromises was not confirmed at the time.</a:t>
+              <a:t>E o lecție despre dezvăluirea coordonată (coordinated disclosure). În mod normal: cercetătorul raportează în privat, producătorul repară, distribuțiile Linux pregătesc pachetele și toți publică în aceeași zi, ca administratorii să poată actualiza înainte să atace cineva.
+Aici: Wiz Research găsește bug-urile în august (folosind și modele AI) și demonstrează atacul pe WordPress și Drupal. Pe 21 septembrie echipa PHP confirmă și începe lucrul. Pe 20 octombrie identificatorii CVE apar pe Hacker News înainte de termen. În noaptea de 21 octombrie o arhivă cu detalii apare pe VirusTotal, iar dimineața Patchstack și Cloudflare raportează primele încercări de atac, cu ore înainte să existe patch-ul. Practic o fereastră de zero-day.
+La 13:52 UTC PHP publică versiunile reparate; CISA, CERT-EU și NCSC (Marea Britanie) emit alerte urgente; apar PoC-uri publice, unele nefuncționale.
+Atenție la formulare: la momentul prezentării nu se știe încă câte atacuri au reușit.
+— English —
+This is a lesson in coordinated disclosure. Normally: researcher reports privately, vendor fixes, distros prepare packages, everyone publishes on the same day. Here the CVE IDs leaked a day early and an archive with details hit VirusTotal, so attacks started hours BEFORE the patch existed. That is effectively a zero-day window. Note: reports of attacks are early; the number of successful compromises was not confirmed at the time.</a:t>
             </a:r>
             <a:endParaRPr lang="en-US" dirty="0"/>
           </a:p>
@@ -1514,7 +1568,12 @@
           <a:p>
             <a:r>
               <a:rPr lang="en-US" dirty="0"/>
-              <a:t>Updating is the ONLY complete fix; the advisory says there is no complete configuration workaround. Practical gotcha: 'php -v' on the command line may be a different PHP than the one serving the website (FPM, a container, a hosting panel). After updating you must restart the workers, otherwise the old binary keeps running in memory.</a:t>
+              <a:t>Versiunile reparate, publicate pe 21 octombrie: 8.5.12, 8.4.27, 8.3.36, 8.2.35. PHP 8.1 și mai vechi nu mai sunt suportate: nu primesc versiune oficială, doar corecții la nivel de cod sursă pentru 7.4–8.1 sau pachete de la distribuții (Ubuntu, Red Hat etc.).
+Ce schimbă patch-ul, pe scurt: curățarea nu mai lucrează cu date pe jumătate construite, starea globală e resetată între cereri, iar un worker care atinge limita de memorie e oprit, nu continuă.
+Actualizarea e SINGURA soluție completă; advisory-ul spune clar că nu există o configurare care să elimine complet problema.
+Capcană practică: „php -v” din terminal poate fi alt PHP decât cel care servește site-ul (FPM, container, panoul de hosting). Și după actualizare trebuie repornite procesele, altfel binarul vechi rulează în continuare în memorie.
+— English —
+Updating is the ONLY complete fix; the advisory says there is no complete configuration workaround. Practical gotcha: 'php -v' on the command line may be a different PHP than the one serving the website (FPM, a container, a hosting panel). After updating you must restart the workers, otherwise the old binary keeps running in memory.</a:t>
             </a:r>
             <a:endParaRPr lang="en-US" dirty="0"/>
           </a:p>

</xml_diff>